<commit_message>
docs: record WP0 WP1 merge evidence
</commit_message>
<xml_diff>
--- a/docs/AI-KM-Phase1-Weekly-2026-W33-v2.6.pptx
+++ b/docs/AI-KM-Phase1-Weekly-2026-W33-v2.6.pptx
@@ -27019,7 +27019,7 @@
                 <a:ea typeface="Microsoft JhengHei" pitchFamily="34" charset="-122"/>
                 <a:cs typeface="Microsoft JhengHei" pitchFamily="34" charset="-120"/>
               </a:rPr>
-              <a:t>85%／87%</a:t>
+              <a:t>94%／96%</a:t>
             </a:r>
             <a:endParaRPr lang="en-US" sz="1600" dirty="0"/>
           </a:p>
@@ -27689,7 +27689,7 @@
                 <a:ea typeface="Aptos" pitchFamily="34" charset="-122"/>
                 <a:cs typeface="Aptos" pitchFamily="34" charset="-120"/>
               </a:rPr>
-              <a:t>85%</a:t>
+              <a:t>94%</a:t>
             </a:r>
             <a:endParaRPr lang="en-US" sz="1400" dirty="0"/>
           </a:p>
@@ -27839,7 +27839,7 @@
                 <a:ea typeface="Aptos" pitchFamily="34" charset="-122"/>
                 <a:cs typeface="Aptos" pitchFamily="34" charset="-120"/>
               </a:rPr>
-              <a:t>87%</a:t>
+              <a:t>96%</a:t>
             </a:r>
             <a:endParaRPr lang="en-US" sz="1400" dirty="0"/>
           </a:p>
@@ -29003,7 +29003,7 @@
                 <a:ea typeface="Microsoft JhengHei" pitchFamily="34" charset="-122"/>
                 <a:cs typeface="Microsoft JhengHei" pitchFamily="34" charset="-120"/>
               </a:rPr>
-              <a:t>WP0｜85%</a:t>
+              <a:t>WP0｜94%</a:t>
             </a:r>
             <a:endParaRPr lang="en-US" sz="2500" dirty="0"/>
           </a:p>
@@ -30172,7 +30172,7 @@
                 <a:ea typeface="Microsoft JhengHei" pitchFamily="34" charset="-122"/>
                 <a:cs typeface="Microsoft JhengHei" pitchFamily="34" charset="-120"/>
               </a:rPr>
-              <a:t>WP1｜87%</a:t>
+              <a:t>WP1｜96%</a:t>
             </a:r>
             <a:endParaRPr lang="en-US" sz="2500" dirty="0"/>
           </a:p>

</xml_diff>

<commit_message>
docs: correct W33 baseline and publish W34 acceptance update
</commit_message>
<xml_diff>
--- a/docs/AI-KM-Phase1-Weekly-2026-W33-v2.6.pptx
+++ b/docs/AI-KM-Phase1-Weekly-2026-W33-v2.6.pptx
@@ -27019,7 +27019,7 @@
                 <a:ea typeface="Microsoft JhengHei" pitchFamily="34" charset="-122"/>
                 <a:cs typeface="Microsoft JhengHei" pitchFamily="34" charset="-120"/>
               </a:rPr>
-              <a:t>94%／96%</a:t>
+              <a:t>85%／87%</a:t>
             </a:r>
             <a:endParaRPr lang="en-US" sz="1600" dirty="0"/>
           </a:p>
@@ -27689,7 +27689,7 @@
                 <a:ea typeface="Aptos" pitchFamily="34" charset="-122"/>
                 <a:cs typeface="Aptos" pitchFamily="34" charset="-120"/>
               </a:rPr>
-              <a:t>94%</a:t>
+              <a:t>85%</a:t>
             </a:r>
             <a:endParaRPr lang="en-US" sz="1400" dirty="0"/>
           </a:p>
@@ -27839,7 +27839,7 @@
                 <a:ea typeface="Aptos" pitchFamily="34" charset="-122"/>
                 <a:cs typeface="Aptos" pitchFamily="34" charset="-120"/>
               </a:rPr>
-              <a:t>96%</a:t>
+              <a:t>87%</a:t>
             </a:r>
             <a:endParaRPr lang="en-US" sz="1400" dirty="0"/>
           </a:p>
@@ -29003,7 +29003,7 @@
                 <a:ea typeface="Microsoft JhengHei" pitchFamily="34" charset="-122"/>
                 <a:cs typeface="Microsoft JhengHei" pitchFamily="34" charset="-120"/>
               </a:rPr>
-              <a:t>WP0｜94%</a:t>
+              <a:t>WP0｜85%</a:t>
             </a:r>
             <a:endParaRPr lang="en-US" sz="2500" dirty="0"/>
           </a:p>
@@ -30172,7 +30172,7 @@
                 <a:ea typeface="Microsoft JhengHei" pitchFamily="34" charset="-122"/>
                 <a:cs typeface="Microsoft JhengHei" pitchFamily="34" charset="-120"/>
               </a:rPr>
-              <a:t>WP1｜96%</a:t>
+              <a:t>WP1｜87%</a:t>
             </a:r>
             <a:endParaRPr lang="en-US" sz="2500" dirty="0"/>
           </a:p>

</xml_diff>